<commit_message>
Update 3rd progress presentation
</commit_message>
<xml_diff>
--- a/Thesis/3rdProgress.pptx
+++ b/Thesis/3rdProgress.pptx
@@ -7491,34 +7491,66 @@
       </p:grpSpPr>
       <p:pic>
         <p:nvPicPr>
-          <p:cNvPr id="3" name="Picture 2"/>
+          <p:cNvPr id="4" name="Picture 3"/>
           <p:cNvPicPr>
             <a:picLocks noChangeAspect="1"/>
           </p:cNvPicPr>
           <p:nvPr/>
         </p:nvPicPr>
         <p:blipFill>
-          <a:blip r:embed="rId2">
-            <a:extLst>
-              <a:ext uri="{28A0092B-C50C-407E-A947-70E740481C1C}">
-                <a14:useLocalDpi xmlns:a14="http://schemas.microsoft.com/office/drawing/2010/main" val="0"/>
-              </a:ext>
-            </a:extLst>
-          </a:blip>
+          <a:blip r:embed="rId2"/>
           <a:stretch>
             <a:fillRect/>
           </a:stretch>
         </p:blipFill>
         <p:spPr>
           <a:xfrm>
-            <a:off x="0" y="0"/>
-            <a:ext cx="12192000" cy="6858000"/>
+            <a:off x="614504" y="1904857"/>
+            <a:ext cx="8315325" cy="2038350"/>
           </a:xfrm>
           <a:prstGeom prst="rect">
             <a:avLst/>
           </a:prstGeom>
         </p:spPr>
       </p:pic>
+      <p:sp>
+        <p:nvSpPr>
+          <p:cNvPr id="5" name="TextBox 4"/>
+          <p:cNvSpPr txBox="1"/>
+          <p:nvPr/>
+        </p:nvSpPr>
+        <p:spPr>
+          <a:xfrm>
+            <a:off x="614504" y="368488"/>
+            <a:ext cx="9621671" cy="769441"/>
+          </a:xfrm>
+          <a:prstGeom prst="rect">
+            <a:avLst/>
+          </a:prstGeom>
+          <a:noFill/>
+        </p:spPr>
+        <p:txBody>
+          <a:bodyPr wrap="square" rtlCol="0">
+            <a:spAutoFit/>
+          </a:bodyPr>
+          <a:lstStyle/>
+          <a:p>
+            <a:r>
+              <a:rPr lang="en-US" sz="4400" dirty="0" smtClean="0">
+                <a:solidFill>
+                  <a:srgbClr val="00B0F0"/>
+                </a:solidFill>
+              </a:rPr>
+              <a:t>Project Implementation Schedule</a:t>
+            </a:r>
+            <a:endParaRPr lang="en-US" sz="4400" dirty="0">
+              <a:solidFill>
+                <a:srgbClr val="00B0F0"/>
+              </a:solidFill>
+            </a:endParaRPr>
+          </a:p>
+        </p:txBody>
+      </p:sp>
     </p:spTree>
     <p:extLst>
       <p:ext uri="{BB962C8B-B14F-4D97-AF65-F5344CB8AC3E}">

</xml_diff>